<commit_message>
feat(grafana): update presentation 'monitoring grafana'
</commit_message>
<xml_diff>
--- a/grafana_bot_presentation.pptx
+++ b/grafana_bot_presentation.pptx
@@ -127,7 +127,7 @@
   <p:extLst>
     <p:ext uri="{521415D9-36F7-43E2-AB2F-B90AF26B5E84}">
       <p14:sectionLst xmlns:p14="http://schemas.microsoft.com/office/powerpoint/2010/main">
-        <p14:section name="Зачем и как это устроено" id="{6e584794-d93a-de64-6cd5-4985bc2c09e6}">
+        <p14:section name="Зачем и как это устроено" id="{de438e8c-8e21-9f3a-2a6b-03902c96a6fd}">
           <p14:sldIdLst>
             <p14:sldId id="256"/>
             <p14:sldId id="257"/>
@@ -139,13 +139,13 @@
             <p14:sldId id="263"/>
           </p14:sldIdLst>
         </p14:section>
-        <p14:section name="Реализация" id="{f0b19c34-4779-1010-9ade-9dbfa03fdaa2}">
+        <p14:section name="Реализация" id="{79914410-cf78-028a-abf9-eb2e5b3748c2}">
           <p14:sldIdLst>
             <p14:sldId id="264"/>
             <p14:sldId id="265"/>
           </p14:sldIdLst>
         </p14:section>
-        <p14:section name="Результат" id="{8dcb35cb-f30e-6d1f-868f-5e75705d82de}">
+        <p14:section name="Результат" id="{e8d8a6bb-19a6-f1fe-4591-5415dae3c264}">
           <p14:sldIdLst>
             <p14:sldId id="266"/>
             <p14:sldId id="267"/>
@@ -156,7 +156,7 @@
             <p14:sldId id="276"/>
           </p14:sldIdLst>
         </p14:section>
-        <p14:section name="Алерты и итоги" id="{860b99dd-9b33-ac9b-437e-dcee7e2fe645}">
+        <p14:section name="Алерты и итоги" id="{dc039847-aae9-9551-2621-89f107822a11}">
           <p14:sldIdLst>
             <p14:sldId id="272"/>
             <p14:sldId id="273"/>
@@ -1712,7 +1712,7 @@
           <a:p>
             <a:r>
               <a:rPr lang="en-US" dirty="0"/>
-              <a:t>Дальше хочу настроить автоматические уведомления, это как раз пункт из моего задания, и подключить Loki для логов. Если есть вопросы, с радостью отвечу.</a:t>
+              <a:t>Уведомления в Telegram уже работают, так что дальше хочу расширить алерты на другие метрики, перенести пользователей в базу данных и подключить Loki для логов. По QR-коду можно открыть материалы. Если есть вопросы, с радостью отвечу.</a:t>
             </a:r>
             <a:endParaRPr lang="en-US" dirty="0"/>
           </a:p>
@@ -10407,7 +10407,7 @@
         <p:spPr>
           <a:xfrm>
             <a:off x="640080" y="1920240"/>
-            <a:ext cx="10515600" cy="2377440"/>
+            <a:ext cx="8595360" cy="2377440"/>
           </a:xfrm>
           <a:prstGeom prst="rect">
             <a:avLst/>
@@ -10501,7 +10501,7 @@
         <p:spPr>
           <a:xfrm>
             <a:off x="640080" y="4572000"/>
-            <a:ext cx="10515600" cy="1097280"/>
+            <a:ext cx="8595360" cy="1097280"/>
           </a:xfrm>
           <a:prstGeom prst="rect">
             <a:avLst/>
@@ -10525,6 +10525,73 @@
               <a:t>Спасибо! Вопросы?</a:t>
             </a:r>
             <a:endParaRPr lang="en-US" sz="5400" dirty="0"/>
+          </a:p>
+        </p:txBody>
+      </p:sp>
+      <p:pic>
+        <p:nvPicPr>
+          <p:cNvPr id="6" name="QR-код" descr="QR-код">    </p:cNvPr>
+          <p:cNvPicPr>
+            <a:picLocks noChangeAspect="1"/>
+          </p:cNvPicPr>
+          <p:nvPr/>
+        </p:nvPicPr>
+        <p:blipFill>
+          <a:blip r:embed="rId1"/>
+          <a:stretch>
+            <a:fillRect/>
+          </a:stretch>
+        </p:blipFill>
+        <p:spPr>
+          <a:xfrm>
+            <a:off x="9537192" y="3566160"/>
+            <a:ext cx="2011680" cy="2011680"/>
+          </a:xfrm>
+          <a:prstGeom prst="rect">
+            <a:avLst/>
+          </a:prstGeom>
+          <a:effectLst>
+            <a:outerShdw sx="100000" sy="100000" kx="0" ky="0" algn="bl" rotWithShape="0" blurRad="101600" dist="25400" dir="5400000">
+              <a:srgbClr val="000000">
+                <a:alpha val="20000"/>
+              </a:srgbClr>
+            </a:outerShdw>
+          </a:effectLst>
+        </p:spPr>
+      </p:pic>
+      <p:sp>
+        <p:nvSpPr>
+          <p:cNvPr id="7" name="QR caption"/>
+          <p:cNvSpPr txBox="1"/>
+          <p:nvPr/>
+        </p:nvSpPr>
+        <p:spPr>
+          <a:xfrm>
+            <a:off x="9537192" y="5669280"/>
+            <a:ext cx="2011680" cy="320040"/>
+          </a:xfrm>
+          <a:prstGeom prst="rect">
+            <a:avLst/>
+          </a:prstGeom>
+          <a:noFill/>
+          <a:ln/>
+        </p:spPr>
+        <p:txBody>
+          <a:bodyPr wrap="square" lIns="0" tIns="0" rIns="0" bIns="0" rtlCol="0" anchor="ctr"/>
+          <a:lstStyle/>
+          <a:p>
+            <a:pPr algn="ctr" indent="0" marL="0">
+              <a:buNone/>
+            </a:pPr>
+            <a:r>
+              <a:rPr lang="en-US" sz="1400" dirty="0">
+                <a:solidFill>
+                  <a:schemeClr val="tx1"/>
+                </a:solidFill>
+              </a:rPr>
+              <a:t>Сканируйте QR-код</a:t>
+            </a:r>
+            <a:endParaRPr lang="en-US" sz="1400" dirty="0"/>
           </a:p>
         </p:txBody>
       </p:sp>

</xml_diff>